<commit_message>
Rename Qlik Sense → Qlik Cloud Analytics; brand the config UI; OTel in Help
- Rename: every "Qlik Sense" reference becomes "Qlik Cloud Analytics" across the
  deck, README, docs and config UI (the Prometheus→QVD path now lands in a
  "Qlik Cloud Analytics app"). Deck rebuilt + re-merged.
- Config UI (per the Brand & Template doc): new status top bar — loopback chip,
  config-file path, keyring backend, and a one-click theme cycle. Dark theme now
  lifts the accent to brand green #15B85F (was cyan) per the spec.
- Help tab: new "Export to Datadog & Splunk (OpenTelemetry)" panel — the otel
  profile command, credential env vars, optional traces, and a link to
  docs/otel-export.md.

Verified: tsc clean, 73/73 tests, live UI smoke (status bar + theme cycle + OTel
panel render; zero "Qlik Sense" left in the served UI).

Co-Authored-By: Claude Opus 4.8 (1M context) <noreply@anthropic.com>
</commit_message>
<xml_diff>
--- a/Qlik-Observability-Toolkit-Architecture-Qlik.pptx
+++ b/Qlik-Observability-Toolkit-Architecture-Qlik.pptx
@@ -14879,7 +14879,7 @@
                 <a:ea typeface="Inter" pitchFamily="34" charset="-122"/>
                 <a:cs typeface="Inter" pitchFamily="34" charset="-120"/>
               </a:rPr>
-              <a:t>MCP server · Prometheus · Loki · Grafana · Python exporters · OpenTelemetry · Qlik Sense</a:t>
+              <a:t>MCP server · Prometheus · Loki · Grafana · Python exporters · OpenTelemetry · Qlik Cloud Analytics</a:t>
             </a:r>
             <a:endParaRPr lang="en-US" sz="1600" dirty="0"/>
           </a:p>
@@ -16987,7 +16987,7 @@
                 <a:ea typeface="Inter" pitchFamily="34" charset="-122"/>
                 <a:cs typeface="Inter" pitchFamily="34" charset="-120"/>
               </a:rPr>
-              <a:t>Qlik Sense Cloud app</a:t>
+              <a:t>Qlik Cloud Analytics app</a:t>
             </a:r>
             <a:endParaRPr lang="en-US" sz="1200" dirty="0"/>
           </a:p>

</xml_diff>